<commit_message>
Deck: replace synthetic metrics with novelty and problem solved per agent
- Slide 2 Result card: four qualitative outcomes instead of demo numbers
- Slide 4: no synthetic truck counts
- Slide 5: 'What's new: four agents, four problems solved' (problem today vs
  what's new for Buy, Sell, Negotiate, Fleet), one-line roadmap, closing line
- Speaker notes updated to match

Co-Authored-By: Claude Opus 5.5 (1M context) <noreply@anthropic.com>
</commit_message>
<xml_diff>
--- a/GoingOnce.pptx
+++ b/GoingOnce.pptx
@@ -111,27 +111,27 @@
   <p:extLst>
     <p:ext uri="{521415D9-36F7-43E2-AB2F-B90AF26B5E84}">
       <p14:sectionLst xmlns:p14="http://schemas.microsoft.com/office/powerpoint/2010/main">
-        <p14:section name="Opening" id="{ada844ee-8122-43b5-070b-2dfb5bfe1415}">
+        <p14:section name="Opening" id="{e67a3a8e-344e-5e73-79dc-39a972f2b0ab}">
           <p14:sldIdLst>
             <p14:sldId id="256"/>
           </p14:sldIdLst>
         </p14:section>
-        <p14:section name="Problem and solution" id="{4167b064-87ea-e60f-9ff5-c46d558c0abd}">
+        <p14:section name="Problem and solution" id="{9ad018c9-18f5-756f-2fba-676aa5211328}">
           <p14:sldIdLst>
             <p14:sldId id="257"/>
           </p14:sldIdLst>
         </p14:section>
-        <p14:section name="Demo" id="{11ffff5c-ed75-35fd-6076-d77c55dce9e9}">
+        <p14:section name="Demo" id="{745370d5-60b5-ca40-a8af-56d18c855531}">
           <p14:sldIdLst>
             <p14:sldId id="258"/>
           </p14:sldIdLst>
         </p14:section>
-        <p14:section name="AI for Good" id="{6c10338d-5d86-6257-e0e6-d00354231922}">
+        <p14:section name="AI for Good" id="{ef798c32-76df-1b3e-cdd7-34604ddbb3a5}">
           <p14:sldIdLst>
             <p14:sldId id="259"/>
           </p14:sldIdLst>
         </p14:section>
-        <p14:section name="Impact and next steps" id="{d315072a-988f-12aa-be85-d32ff5f3fc7d}">
+        <p14:section name="What's new" id="{f2c0055e-9a86-7d6a-0eed-23ae281903c0}">
           <p14:sldIdLst>
             <p14:sldId id="260"/>
           </p14:sldIdLst>
@@ -633,7 +633,7 @@
 Situation: ACV runs 20-minute online auctions for dealers, Copart sells damaged cars to buyers worldwide, and they're becoming one company. But cars still go unsold: the right buyer isn't watching, the price doesn't meet, or hidden damage scares buyers off. And ACV only earns on a sale.
 Task: turn more listings into sales, catch hidden damage before anyone buys, and move cars at the lowest cost.
 Action: GoingOnce is four AI agents that do the work while people approve every money step: Buy, Sell, Negotiate, Fleet.
-Result, in our demo: a flood car caught before purchase, three buyers lined up before the auction, a $3,000 price gap closed, and $349K more for one fleet. Let's see it.</a:t>
+Result: hidden damage is caught before anyone buys, buyers are lined up before the auction starts, price gaps get closed instead of killing the deal, and fleets sell without flooding a market. Let's see it.</a:t>
             </a:r>
             <a:endParaRPr lang="en-US" dirty="0"/>
           </a:p>
@@ -725,7 +725,7 @@
 Buy: 'Reason one: buyers can't find the right car, or can't trust it. It searched ACV and Copart and checked every car's history. This cheap one was flooded and hidden behind a clean title. Nothing is bought without his OK.'
 Sell: 'Reason two: the right buyer isn't watching during the auction. AI wrote the condition report, ACV pays her the most, and three buyers are already waiting, including the dealer we just saw.'
 Negotiate: 'Reason three: the seller wants $15,000, the top bid is $12,000. The AI shows real market prices, they meet in three rounds, and it closes itself: payment, insurance, loan payoff, title, truck.'
-Fleet: 'Reason four is scale. 120 rental cars in full trucks to seven cities: $349K more, $108 a car to ship.'
+Fleet: 'Reason four is scale. A rental company sells 120 similar cars at once. The agent spreads them across cities in full trucks, so prices hold and shipping stays cheap.'
 To add the video: Insert &gt; Video &gt; Video from File, then drag it over the dark area on the left.</a:t>
             </a:r>
             <a:endParaRPr lang="en-US" dirty="0"/>
@@ -904,7 +904,7 @@
             <a:r>
               <a:rPr lang="en-US" dirty="0"/>
               <a:t>4:25–5:00
-For ACV: every rescued deal is revenue that would have been zero, like the $876 in our demo, and fleets earn far more with lower transport. Today it's four working agents on demo data. Next, connect them to ACV and Copart's real inventory, inspections, financing and transport. Then, a Car Health Score that lenders and insurers can use, and more buyers worldwide. We shaped this with feedback from ACV's mentors. Going once, going twice... sold. Thank you.</a:t>
+What's new? Buy joins ACV and Copart records, so it catches title-washed cars no single company can see. Sell flips the auction: the car finds its buyer before the auction even starts. Negotiate keeps each side's limit private, closes the gap, and then closes the deal on its own. Fleet plans where every truckload goes, so a big fleet sale doesn't crash prices. Next, we connect it to ACV and Copart's real systems, then build a Car Health Score for lenders and insurers. Going once, going twice... sold. Thank you.</a:t>
             </a:r>
             <a:endParaRPr lang="en-US" dirty="0"/>
           </a:p>
@@ -3459,16 +3459,16 @@
         <p:spPr>
           <a:xfrm>
             <a:off x="9303791" y="2697480"/>
-            <a:ext cx="2110664" cy="292608"/>
-          </a:xfrm>
-          <a:prstGeom prst="rect">
-            <a:avLst/>
-          </a:prstGeom>
-          <a:noFill/>
-          <a:ln/>
-        </p:spPr>
-        <p:txBody>
-          <a:bodyPr wrap="square" lIns="0" tIns="0" rIns="0" bIns="0" rtlCol="0" anchor="ctr"/>
+            <a:ext cx="2110664" cy="502920"/>
+          </a:xfrm>
+          <a:prstGeom prst="rect">
+            <a:avLst/>
+          </a:prstGeom>
+          <a:noFill/>
+          <a:ln/>
+        </p:spPr>
+        <p:txBody>
+          <a:bodyPr wrap="square" lIns="0" tIns="0" rIns="0" bIns="0" rtlCol="0" anchor="t"/>
           <a:lstStyle/>
           <a:p>
             <a:pPr indent="0" marL="0">
@@ -3480,309 +3480,249 @@
                   <a:schemeClr val="tx2"/>
                 </a:solidFill>
               </a:rPr>
-              <a:t>In our demo:</a:t>
+              <a:t>What changes:</a:t>
             </a:r>
             <a:endParaRPr lang="en-US" sz="1400" dirty="0"/>
           </a:p>
         </p:txBody>
       </p:sp>
-      <p:sp>
-        <p:nvSpPr>
-          <p:cNvPr id="33" name="Result 1 number"/>
-          <p:cNvSpPr txBox="1"/>
-          <p:nvPr/>
-        </p:nvSpPr>
-        <p:spPr>
-          <a:xfrm>
-            <a:off x="9303791" y="3108960"/>
-            <a:ext cx="2110664" cy="384048"/>
-          </a:xfrm>
-          <a:prstGeom prst="rect">
-            <a:avLst/>
-          </a:prstGeom>
-          <a:noFill/>
-          <a:ln/>
-        </p:spPr>
-        <p:txBody>
-          <a:bodyPr wrap="square" lIns="0" tIns="0" rIns="0" bIns="0" rtlCol="0" anchor="ctr"/>
+      <p:pic>
+        <p:nvPicPr>
+          <p:cNvPr id="33" name="Result 1 icon" descr="preencoded.png">    </p:cNvPr>
+          <p:cNvPicPr>
+            <a:picLocks noChangeAspect="1"/>
+          </p:cNvPicPr>
+          <p:nvPr/>
+        </p:nvPicPr>
+        <p:blipFill>
+          <a:blip r:embed="rId5"/>
+          <a:stretch>
+            <a:fillRect/>
+          </a:stretch>
+        </p:blipFill>
+        <p:spPr>
+          <a:xfrm>
+            <a:off x="9303791" y="3355848"/>
+            <a:ext cx="274320" cy="274320"/>
+          </a:xfrm>
+          <a:prstGeom prst="rect">
+            <a:avLst/>
+          </a:prstGeom>
+        </p:spPr>
+      </p:pic>
+      <p:sp>
+        <p:nvSpPr>
+          <p:cNvPr id="34" name="Result 1 text"/>
+          <p:cNvSpPr txBox="1"/>
+          <p:nvPr/>
+        </p:nvSpPr>
+        <p:spPr>
+          <a:xfrm>
+            <a:off x="9687839" y="3319272"/>
+            <a:ext cx="1726616" cy="566928"/>
+          </a:xfrm>
+          <a:prstGeom prst="rect">
+            <a:avLst/>
+          </a:prstGeom>
+          <a:noFill/>
+          <a:ln/>
+        </p:spPr>
+        <p:txBody>
+          <a:bodyPr wrap="square" lIns="0" tIns="0" rIns="0" bIns="0" rtlCol="0" anchor="t"/>
           <a:lstStyle/>
           <a:p>
             <a:pPr indent="0" marL="0">
               <a:buNone/>
             </a:pPr>
             <a:r>
-              <a:rPr lang="en-US" sz="2400" b="1" dirty="0">
-                <a:solidFill>
-                  <a:schemeClr val="accent1"/>
-                </a:solidFill>
-                <a:latin typeface="+mj-lt" pitchFamily="34" charset="0"/>
-                <a:ea typeface="+mj-lt" pitchFamily="34" charset="-122"/>
-                <a:cs typeface="+mj-lt" pitchFamily="34" charset="-120"/>
-              </a:rPr>
-              <a:t>1</a:t>
-            </a:r>
-            <a:endParaRPr lang="en-US" sz="2400" dirty="0"/>
-          </a:p>
-        </p:txBody>
-      </p:sp>
-      <p:sp>
-        <p:nvSpPr>
-          <p:cNvPr id="34" name="Result 1 caption"/>
-          <p:cNvSpPr txBox="1"/>
-          <p:nvPr/>
-        </p:nvSpPr>
-        <p:spPr>
-          <a:xfrm>
-            <a:off x="9303791" y="3493008"/>
-            <a:ext cx="2110664" cy="274320"/>
-          </a:xfrm>
-          <a:prstGeom prst="rect">
-            <a:avLst/>
-          </a:prstGeom>
-          <a:noFill/>
-          <a:ln/>
-        </p:spPr>
-        <p:txBody>
-          <a:bodyPr wrap="square" lIns="0" tIns="0" rIns="0" bIns="0" rtlCol="0" anchor="ctr"/>
+              <a:rPr lang="en-US" sz="1400" dirty="0">
+                <a:solidFill>
+                  <a:schemeClr val="tx1"/>
+                </a:solidFill>
+              </a:rPr>
+              <a:t>Hidden damage caught before anyone buys</a:t>
+            </a:r>
+            <a:endParaRPr lang="en-US" sz="1400" dirty="0"/>
+          </a:p>
+        </p:txBody>
+      </p:sp>
+      <p:pic>
+        <p:nvPicPr>
+          <p:cNvPr id="35" name="Result 2 icon" descr="preencoded.png">    </p:cNvPr>
+          <p:cNvPicPr>
+            <a:picLocks noChangeAspect="1"/>
+          </p:cNvPicPr>
+          <p:nvPr/>
+        </p:nvPicPr>
+        <p:blipFill>
+          <a:blip r:embed="rId6"/>
+          <a:stretch>
+            <a:fillRect/>
+          </a:stretch>
+        </p:blipFill>
+        <p:spPr>
+          <a:xfrm>
+            <a:off x="9303791" y="4123944"/>
+            <a:ext cx="274320" cy="274320"/>
+          </a:xfrm>
+          <a:prstGeom prst="rect">
+            <a:avLst/>
+          </a:prstGeom>
+        </p:spPr>
+      </p:pic>
+      <p:sp>
+        <p:nvSpPr>
+          <p:cNvPr id="36" name="Result 2 text"/>
+          <p:cNvSpPr txBox="1"/>
+          <p:nvPr/>
+        </p:nvSpPr>
+        <p:spPr>
+          <a:xfrm>
+            <a:off x="9687839" y="4087368"/>
+            <a:ext cx="1726616" cy="566928"/>
+          </a:xfrm>
+          <a:prstGeom prst="rect">
+            <a:avLst/>
+          </a:prstGeom>
+          <a:noFill/>
+          <a:ln/>
+        </p:spPr>
+        <p:txBody>
+          <a:bodyPr wrap="square" lIns="0" tIns="0" rIns="0" bIns="0" rtlCol="0" anchor="t"/>
           <a:lstStyle/>
           <a:p>
             <a:pPr indent="0" marL="0">
               <a:buNone/>
             </a:pPr>
             <a:r>
-              <a:rPr lang="en-US" sz="1200" dirty="0">
+              <a:rPr lang="en-US" sz="1400" dirty="0">
                 <a:solidFill>
                   <a:schemeClr val="tx1"/>
                 </a:solidFill>
               </a:rPr>
-              <a:t>flood car caught before purchase</a:t>
-            </a:r>
-            <a:endParaRPr lang="en-US" sz="1200" dirty="0"/>
-          </a:p>
-        </p:txBody>
-      </p:sp>
-      <p:sp>
-        <p:nvSpPr>
-          <p:cNvPr id="35" name="Result 2 number"/>
-          <p:cNvSpPr txBox="1"/>
-          <p:nvPr/>
-        </p:nvSpPr>
-        <p:spPr>
-          <a:xfrm>
-            <a:off x="9303791" y="3877056"/>
-            <a:ext cx="2110664" cy="384048"/>
-          </a:xfrm>
-          <a:prstGeom prst="rect">
-            <a:avLst/>
-          </a:prstGeom>
-          <a:noFill/>
-          <a:ln/>
-        </p:spPr>
-        <p:txBody>
-          <a:bodyPr wrap="square" lIns="0" tIns="0" rIns="0" bIns="0" rtlCol="0" anchor="ctr"/>
+              <a:t>Buyers lined up before the auction starts</a:t>
+            </a:r>
+            <a:endParaRPr lang="en-US" sz="1400" dirty="0"/>
+          </a:p>
+        </p:txBody>
+      </p:sp>
+      <p:pic>
+        <p:nvPicPr>
+          <p:cNvPr id="37" name="Result 3 icon" descr="preencoded.png">    </p:cNvPr>
+          <p:cNvPicPr>
+            <a:picLocks noChangeAspect="1"/>
+          </p:cNvPicPr>
+          <p:nvPr/>
+        </p:nvPicPr>
+        <p:blipFill>
+          <a:blip r:embed="rId7"/>
+          <a:stretch>
+            <a:fillRect/>
+          </a:stretch>
+        </p:blipFill>
+        <p:spPr>
+          <a:xfrm>
+            <a:off x="9303791" y="4892040"/>
+            <a:ext cx="274320" cy="274320"/>
+          </a:xfrm>
+          <a:prstGeom prst="rect">
+            <a:avLst/>
+          </a:prstGeom>
+        </p:spPr>
+      </p:pic>
+      <p:sp>
+        <p:nvSpPr>
+          <p:cNvPr id="38" name="Result 3 text"/>
+          <p:cNvSpPr txBox="1"/>
+          <p:nvPr/>
+        </p:nvSpPr>
+        <p:spPr>
+          <a:xfrm>
+            <a:off x="9687839" y="4855464"/>
+            <a:ext cx="1726616" cy="566928"/>
+          </a:xfrm>
+          <a:prstGeom prst="rect">
+            <a:avLst/>
+          </a:prstGeom>
+          <a:noFill/>
+          <a:ln/>
+        </p:spPr>
+        <p:txBody>
+          <a:bodyPr wrap="square" lIns="0" tIns="0" rIns="0" bIns="0" rtlCol="0" anchor="t"/>
           <a:lstStyle/>
           <a:p>
             <a:pPr indent="0" marL="0">
               <a:buNone/>
             </a:pPr>
             <a:r>
-              <a:rPr lang="en-US" sz="2400" b="1" dirty="0">
-                <a:solidFill>
-                  <a:schemeClr val="accent1"/>
-                </a:solidFill>
-                <a:latin typeface="+mj-lt" pitchFamily="34" charset="0"/>
-                <a:ea typeface="+mj-lt" pitchFamily="34" charset="-122"/>
-                <a:cs typeface="+mj-lt" pitchFamily="34" charset="-120"/>
-              </a:rPr>
-              <a:t>3</a:t>
-            </a:r>
-            <a:endParaRPr lang="en-US" sz="2400" dirty="0"/>
-          </a:p>
-        </p:txBody>
-      </p:sp>
-      <p:sp>
-        <p:nvSpPr>
-          <p:cNvPr id="36" name="Result 2 caption"/>
-          <p:cNvSpPr txBox="1"/>
-          <p:nvPr/>
-        </p:nvSpPr>
-        <p:spPr>
-          <a:xfrm>
-            <a:off x="9303791" y="4261104"/>
-            <a:ext cx="2110664" cy="274320"/>
-          </a:xfrm>
-          <a:prstGeom prst="rect">
-            <a:avLst/>
-          </a:prstGeom>
-          <a:noFill/>
-          <a:ln/>
-        </p:spPr>
-        <p:txBody>
-          <a:bodyPr wrap="square" lIns="0" tIns="0" rIns="0" bIns="0" rtlCol="0" anchor="ctr"/>
+              <a:rPr lang="en-US" sz="1400" dirty="0">
+                <a:solidFill>
+                  <a:schemeClr val="tx1"/>
+                </a:solidFill>
+              </a:rPr>
+              <a:t>Price gaps closed instead of dead deals</a:t>
+            </a:r>
+            <a:endParaRPr lang="en-US" sz="1400" dirty="0"/>
+          </a:p>
+        </p:txBody>
+      </p:sp>
+      <p:pic>
+        <p:nvPicPr>
+          <p:cNvPr id="39" name="Result 4 icon" descr="preencoded.png">    </p:cNvPr>
+          <p:cNvPicPr>
+            <a:picLocks noChangeAspect="1"/>
+          </p:cNvPicPr>
+          <p:nvPr/>
+        </p:nvPicPr>
+        <p:blipFill>
+          <a:blip r:embed="rId8"/>
+          <a:stretch>
+            <a:fillRect/>
+          </a:stretch>
+        </p:blipFill>
+        <p:spPr>
+          <a:xfrm>
+            <a:off x="9303791" y="5660136"/>
+            <a:ext cx="274320" cy="274320"/>
+          </a:xfrm>
+          <a:prstGeom prst="rect">
+            <a:avLst/>
+          </a:prstGeom>
+        </p:spPr>
+      </p:pic>
+      <p:sp>
+        <p:nvSpPr>
+          <p:cNvPr id="40" name="Result 4 text"/>
+          <p:cNvSpPr txBox="1"/>
+          <p:nvPr/>
+        </p:nvSpPr>
+        <p:spPr>
+          <a:xfrm>
+            <a:off x="9687839" y="5623560"/>
+            <a:ext cx="1726616" cy="566928"/>
+          </a:xfrm>
+          <a:prstGeom prst="rect">
+            <a:avLst/>
+          </a:prstGeom>
+          <a:noFill/>
+          <a:ln/>
+        </p:spPr>
+        <p:txBody>
+          <a:bodyPr wrap="square" lIns="0" tIns="0" rIns="0" bIns="0" rtlCol="0" anchor="t"/>
           <a:lstStyle/>
           <a:p>
             <a:pPr indent="0" marL="0">
               <a:buNone/>
             </a:pPr>
             <a:r>
-              <a:rPr lang="en-US" sz="1200" dirty="0">
+              <a:rPr lang="en-US" sz="1400" dirty="0">
                 <a:solidFill>
                   <a:schemeClr val="tx1"/>
                 </a:solidFill>
               </a:rPr>
-              <a:t>buyers waiting before the auction</a:t>
-            </a:r>
-            <a:endParaRPr lang="en-US" sz="1200" dirty="0"/>
-          </a:p>
-        </p:txBody>
-      </p:sp>
-      <p:sp>
-        <p:nvSpPr>
-          <p:cNvPr id="37" name="Result 3 number"/>
-          <p:cNvSpPr txBox="1"/>
-          <p:nvPr/>
-        </p:nvSpPr>
-        <p:spPr>
-          <a:xfrm>
-            <a:off x="9303791" y="4645152"/>
-            <a:ext cx="2110664" cy="384048"/>
-          </a:xfrm>
-          <a:prstGeom prst="rect">
-            <a:avLst/>
-          </a:prstGeom>
-          <a:noFill/>
-          <a:ln/>
-        </p:spPr>
-        <p:txBody>
-          <a:bodyPr wrap="square" lIns="0" tIns="0" rIns="0" bIns="0" rtlCol="0" anchor="ctr"/>
-          <a:lstStyle/>
-          <a:p>
-            <a:pPr indent="0" marL="0">
-              <a:buNone/>
-            </a:pPr>
-            <a:r>
-              <a:rPr lang="en-US" sz="2400" b="1" dirty="0">
-                <a:solidFill>
-                  <a:schemeClr val="accent1"/>
-                </a:solidFill>
-                <a:latin typeface="+mj-lt" pitchFamily="34" charset="0"/>
-                <a:ea typeface="+mj-lt" pitchFamily="34" charset="-122"/>
-                <a:cs typeface="+mj-lt" pitchFamily="34" charset="-120"/>
-              </a:rPr>
-              <a:t>$13,150</a:t>
-            </a:r>
-            <a:endParaRPr lang="en-US" sz="2400" dirty="0"/>
-          </a:p>
-        </p:txBody>
-      </p:sp>
-      <p:sp>
-        <p:nvSpPr>
-          <p:cNvPr id="38" name="Result 3 caption"/>
-          <p:cNvSpPr txBox="1"/>
-          <p:nvPr/>
-        </p:nvSpPr>
-        <p:spPr>
-          <a:xfrm>
-            <a:off x="9303791" y="5029200"/>
-            <a:ext cx="2110664" cy="274320"/>
-          </a:xfrm>
-          <a:prstGeom prst="rect">
-            <a:avLst/>
-          </a:prstGeom>
-          <a:noFill/>
-          <a:ln/>
-        </p:spPr>
-        <p:txBody>
-          <a:bodyPr wrap="square" lIns="0" tIns="0" rIns="0" bIns="0" rtlCol="0" anchor="ctr"/>
-          <a:lstStyle/>
-          <a:p>
-            <a:pPr indent="0" marL="0">
-              <a:buNone/>
-            </a:pPr>
-            <a:r>
-              <a:rPr lang="en-US" sz="1200" dirty="0">
-                <a:solidFill>
-                  <a:schemeClr val="tx1"/>
-                </a:solidFill>
-              </a:rPr>
-              <a:t>deal closed from a $3,000 gap</a:t>
-            </a:r>
-            <a:endParaRPr lang="en-US" sz="1200" dirty="0"/>
-          </a:p>
-        </p:txBody>
-      </p:sp>
-      <p:sp>
-        <p:nvSpPr>
-          <p:cNvPr id="39" name="Result 4 number"/>
-          <p:cNvSpPr txBox="1"/>
-          <p:nvPr/>
-        </p:nvSpPr>
-        <p:spPr>
-          <a:xfrm>
-            <a:off x="9303791" y="5413248"/>
-            <a:ext cx="2110664" cy="384048"/>
-          </a:xfrm>
-          <a:prstGeom prst="rect">
-            <a:avLst/>
-          </a:prstGeom>
-          <a:noFill/>
-          <a:ln/>
-        </p:spPr>
-        <p:txBody>
-          <a:bodyPr wrap="square" lIns="0" tIns="0" rIns="0" bIns="0" rtlCol="0" anchor="ctr"/>
-          <a:lstStyle/>
-          <a:p>
-            <a:pPr indent="0" marL="0">
-              <a:buNone/>
-            </a:pPr>
-            <a:r>
-              <a:rPr lang="en-US" sz="2400" b="1" dirty="0">
-                <a:solidFill>
-                  <a:schemeClr val="accent1"/>
-                </a:solidFill>
-                <a:latin typeface="+mj-lt" pitchFamily="34" charset="0"/>
-                <a:ea typeface="+mj-lt" pitchFamily="34" charset="-122"/>
-                <a:cs typeface="+mj-lt" pitchFamily="34" charset="-120"/>
-              </a:rPr>
-              <a:t>+$349K</a:t>
-            </a:r>
-            <a:endParaRPr lang="en-US" sz="2400" dirty="0"/>
-          </a:p>
-        </p:txBody>
-      </p:sp>
-      <p:sp>
-        <p:nvSpPr>
-          <p:cNvPr id="40" name="Result 4 caption"/>
-          <p:cNvSpPr txBox="1"/>
-          <p:nvPr/>
-        </p:nvSpPr>
-        <p:spPr>
-          <a:xfrm>
-            <a:off x="9303791" y="5797296"/>
-            <a:ext cx="2110664" cy="274320"/>
-          </a:xfrm>
-          <a:prstGeom prst="rect">
-            <a:avLst/>
-          </a:prstGeom>
-          <a:noFill/>
-          <a:ln/>
-        </p:spPr>
-        <p:txBody>
-          <a:bodyPr wrap="square" lIns="0" tIns="0" rIns="0" bIns="0" rtlCol="0" anchor="ctr"/>
-          <a:lstStyle/>
-          <a:p>
-            <a:pPr indent="0" marL="0">
-              <a:buNone/>
-            </a:pPr>
-            <a:r>
-              <a:rPr lang="en-US" sz="1200" dirty="0">
-                <a:solidFill>
-                  <a:schemeClr val="tx1"/>
-                </a:solidFill>
-              </a:rPr>
-              <a:t>for one 120-car fleet</a:t>
-            </a:r>
-            <a:endParaRPr lang="en-US" sz="1200" dirty="0"/>
+              <a:t>Fleets sold without flooding a market</a:t>
+            </a:r>
+            <a:endParaRPr lang="en-US" sz="1400" dirty="0"/>
           </a:p>
         </p:txBody>
       </p:sp>
@@ -4972,7 +4912,7 @@
                   <a:schemeClr val="tx1"/>
                 </a:solidFill>
               </a:rPr>
-              <a:t>14 full trucks instead of 98 single trips. Unsold cars reach buyers worldwide instead of the scrapyard.</a:t>
+              <a:t>Full truckloads instead of single trips. Unsold cars reach buyers worldwide instead of the scrapyard.</a:t>
             </a:r>
             <a:endParaRPr lang="en-US" sz="1500" dirty="0"/>
           </a:p>
@@ -5235,7 +5175,7 @@
                   <a:schemeClr val="bg1"/>
                 </a:solidFill>
               </a:rPr>
-              <a:t>Why it matters for ACV, and what's next</a:t>
+              <a:t>What's new: four agents, four problems solved</a:t>
             </a:r>
             <a:endParaRPr lang="en-US" sz="3600" dirty="0"/>
           </a:p>
@@ -5243,281 +5183,24 @@
       </p:sp>
       <p:sp>
         <p:nvSpPr>
-          <p:cNvPr id="3" name="Stat 1 number"/>
-          <p:cNvSpPr txBox="1"/>
-          <p:nvPr/>
-        </p:nvSpPr>
-        <p:spPr>
-          <a:xfrm>
-            <a:off x="548640" y="1463040"/>
-            <a:ext cx="4937760" cy="731520"/>
-          </a:xfrm>
-          <a:prstGeom prst="rect">
-            <a:avLst/>
-          </a:prstGeom>
-          <a:noFill/>
-          <a:ln/>
-        </p:spPr>
-        <p:txBody>
-          <a:bodyPr wrap="square" lIns="0" tIns="0" rIns="0" bIns="0" rtlCol="0" anchor="ctr"/>
-          <a:lstStyle/>
-          <a:p>
-            <a:pPr indent="0" marL="0">
-              <a:buNone/>
-            </a:pPr>
-            <a:r>
-              <a:rPr lang="en-US" sz="4800" b="1" dirty="0">
-                <a:solidFill>
-                  <a:schemeClr val="accent2"/>
-                </a:solidFill>
-                <a:latin typeface="+mj-lt" pitchFamily="34" charset="0"/>
-                <a:ea typeface="+mj-lt" pitchFamily="34" charset="-122"/>
-                <a:cs typeface="+mj-lt" pitchFamily="34" charset="-120"/>
-              </a:rPr>
-              <a:t>$876</a:t>
-            </a:r>
-            <a:endParaRPr lang="en-US" sz="4800" dirty="0"/>
-          </a:p>
-        </p:txBody>
-      </p:sp>
-      <p:sp>
-        <p:nvSpPr>
-          <p:cNvPr id="4" name="Stat 1 caption"/>
-          <p:cNvSpPr txBox="1"/>
-          <p:nvPr/>
-        </p:nvSpPr>
-        <p:spPr>
-          <a:xfrm>
-            <a:off x="548640" y="2176272"/>
-            <a:ext cx="4937760" cy="329184"/>
-          </a:xfrm>
-          <a:prstGeom prst="rect">
-            <a:avLst/>
-          </a:prstGeom>
-          <a:noFill/>
-          <a:ln/>
-        </p:spPr>
-        <p:txBody>
-          <a:bodyPr wrap="square" lIns="0" tIns="0" rIns="0" bIns="0" rtlCol="0" anchor="ctr"/>
-          <a:lstStyle/>
-          <a:p>
-            <a:pPr indent="0" marL="0">
-              <a:buNone/>
-            </a:pPr>
-            <a:r>
-              <a:rPr lang="en-US" sz="1500" dirty="0">
-                <a:solidFill>
-                  <a:schemeClr val="bg1"/>
-                </a:solidFill>
-              </a:rPr>
-              <a:t>ACV earns on a deal that would have died</a:t>
-            </a:r>
-            <a:endParaRPr lang="en-US" sz="1500" dirty="0"/>
-          </a:p>
-        </p:txBody>
-      </p:sp>
-      <p:sp>
-        <p:nvSpPr>
-          <p:cNvPr id="5" name="Stat 2 number"/>
-          <p:cNvSpPr txBox="1"/>
-          <p:nvPr/>
-        </p:nvSpPr>
-        <p:spPr>
-          <a:xfrm>
-            <a:off x="548640" y="2651760"/>
-            <a:ext cx="4937760" cy="731520"/>
-          </a:xfrm>
-          <a:prstGeom prst="rect">
-            <a:avLst/>
-          </a:prstGeom>
-          <a:noFill/>
-          <a:ln/>
-        </p:spPr>
-        <p:txBody>
-          <a:bodyPr wrap="square" lIns="0" tIns="0" rIns="0" bIns="0" rtlCol="0" anchor="ctr"/>
-          <a:lstStyle/>
-          <a:p>
-            <a:pPr indent="0" marL="0">
-              <a:buNone/>
-            </a:pPr>
-            <a:r>
-              <a:rPr lang="en-US" sz="4800" b="1" dirty="0">
-                <a:solidFill>
-                  <a:schemeClr val="accent2"/>
-                </a:solidFill>
-                <a:latin typeface="+mj-lt" pitchFamily="34" charset="0"/>
-                <a:ea typeface="+mj-lt" pitchFamily="34" charset="-122"/>
-                <a:cs typeface="+mj-lt" pitchFamily="34" charset="-120"/>
-              </a:rPr>
-              <a:t>+$349K</a:t>
-            </a:r>
-            <a:endParaRPr lang="en-US" sz="4800" dirty="0"/>
-          </a:p>
-        </p:txBody>
-      </p:sp>
-      <p:sp>
-        <p:nvSpPr>
-          <p:cNvPr id="6" name="Stat 2 caption"/>
-          <p:cNvSpPr txBox="1"/>
-          <p:nvPr/>
-        </p:nvSpPr>
-        <p:spPr>
-          <a:xfrm>
-            <a:off x="548640" y="3364992"/>
-            <a:ext cx="4937760" cy="329184"/>
-          </a:xfrm>
-          <a:prstGeom prst="rect">
-            <a:avLst/>
-          </a:prstGeom>
-          <a:noFill/>
-          <a:ln/>
-        </p:spPr>
-        <p:txBody>
-          <a:bodyPr wrap="square" lIns="0" tIns="0" rIns="0" bIns="0" rtlCol="0" anchor="ctr"/>
-          <a:lstStyle/>
-          <a:p>
-            <a:pPr indent="0" marL="0">
-              <a:buNone/>
-            </a:pPr>
-            <a:r>
-              <a:rPr lang="en-US" sz="1500" dirty="0">
-                <a:solidFill>
-                  <a:schemeClr val="bg1"/>
-                </a:solidFill>
-              </a:rPr>
-              <a:t>more for one 120-car fleet</a:t>
-            </a:r>
-            <a:endParaRPr lang="en-US" sz="1500" dirty="0"/>
-          </a:p>
-        </p:txBody>
-      </p:sp>
-      <p:sp>
-        <p:nvSpPr>
-          <p:cNvPr id="7" name="Stat 3 number"/>
-          <p:cNvSpPr txBox="1"/>
-          <p:nvPr/>
-        </p:nvSpPr>
-        <p:spPr>
-          <a:xfrm>
-            <a:off x="548640" y="3840480"/>
-            <a:ext cx="4937760" cy="731520"/>
-          </a:xfrm>
-          <a:prstGeom prst="rect">
-            <a:avLst/>
-          </a:prstGeom>
-          <a:noFill/>
-          <a:ln/>
-        </p:spPr>
-        <p:txBody>
-          <a:bodyPr wrap="square" lIns="0" tIns="0" rIns="0" bIns="0" rtlCol="0" anchor="ctr"/>
-          <a:lstStyle/>
-          <a:p>
-            <a:pPr indent="0" marL="0">
-              <a:buNone/>
-            </a:pPr>
-            <a:r>
-              <a:rPr lang="en-US" sz="4800" b="1" dirty="0">
-                <a:solidFill>
-                  <a:schemeClr val="accent2"/>
-                </a:solidFill>
-                <a:latin typeface="+mj-lt" pitchFamily="34" charset="0"/>
-                <a:ea typeface="+mj-lt" pitchFamily="34" charset="-122"/>
-                <a:cs typeface="+mj-lt" pitchFamily="34" charset="-120"/>
-              </a:rPr>
-              <a:t>66%</a:t>
-            </a:r>
-            <a:endParaRPr lang="en-US" sz="4800" dirty="0"/>
-          </a:p>
-        </p:txBody>
-      </p:sp>
-      <p:sp>
-        <p:nvSpPr>
-          <p:cNvPr id="8" name="Stat 3 caption"/>
-          <p:cNvSpPr txBox="1"/>
-          <p:nvPr/>
-        </p:nvSpPr>
-        <p:spPr>
-          <a:xfrm>
-            <a:off x="548640" y="4553712"/>
-            <a:ext cx="4937760" cy="329184"/>
-          </a:xfrm>
-          <a:prstGeom prst="rect">
-            <a:avLst/>
-          </a:prstGeom>
-          <a:noFill/>
-          <a:ln/>
-        </p:spPr>
-        <p:txBody>
-          <a:bodyPr wrap="square" lIns="0" tIns="0" rIns="0" bIns="0" rtlCol="0" anchor="ctr"/>
-          <a:lstStyle/>
-          <a:p>
-            <a:pPr indent="0" marL="0">
-              <a:buNone/>
-            </a:pPr>
-            <a:r>
-              <a:rPr lang="en-US" sz="1500" dirty="0">
-                <a:solidFill>
-                  <a:schemeClr val="bg1"/>
-                </a:solidFill>
-              </a:rPr>
-              <a:t>lower transport cost per car</a:t>
-            </a:r>
-            <a:endParaRPr lang="en-US" sz="1500" dirty="0"/>
-          </a:p>
-        </p:txBody>
-      </p:sp>
-      <p:sp>
-        <p:nvSpPr>
-          <p:cNvPr id="9" name="Stats note"/>
-          <p:cNvSpPr txBox="1"/>
-          <p:nvPr/>
-        </p:nvSpPr>
-        <p:spPr>
-          <a:xfrm>
-            <a:off x="548640" y="4983480"/>
-            <a:ext cx="4937760" cy="274320"/>
-          </a:xfrm>
-          <a:prstGeom prst="rect">
-            <a:avLst/>
-          </a:prstGeom>
-          <a:noFill/>
-          <a:ln/>
-        </p:spPr>
-        <p:txBody>
-          <a:bodyPr wrap="square" lIns="0" tIns="0" rIns="0" bIns="0" rtlCol="0" anchor="ctr"/>
-          <a:lstStyle/>
-          <a:p>
-            <a:pPr indent="0" marL="0">
-              <a:buNone/>
-            </a:pPr>
-            <a:r>
-              <a:rPr lang="en-US" sz="1100" i="1" dirty="0">
-                <a:solidFill>
-                  <a:schemeClr val="bg2"/>
-                </a:solidFill>
-              </a:rPr>
-              <a:t>Numbers from our demo data</a:t>
-            </a:r>
-            <a:endParaRPr lang="en-US" sz="1100" dirty="0"/>
-          </a:p>
-        </p:txBody>
-      </p:sp>
-      <p:sp>
-        <p:nvSpPr>
-          <p:cNvPr id="10" name="Roadmap connector"/>
+          <p:cNvPr id="3" name="Buy card"/>
           <p:cNvSpPr/>
           <p:nvPr/>
         </p:nvSpPr>
         <p:spPr>
           <a:xfrm>
-            <a:off x="6583680" y="1828800"/>
-            <a:ext cx="0" cy="2377440"/>
-          </a:xfrm>
-          <a:prstGeom prst="line">
-            <a:avLst/>
-          </a:prstGeom>
-          <a:noFill/>
-          <a:ln w="38100">
+            <a:off x="548640" y="1371600"/>
+            <a:ext cx="2567864" cy="3611880"/>
+          </a:xfrm>
+          <a:prstGeom prst="roundRect">
+            <a:avLst>
+              <a:gd name="adj" fmla="val 4273"/>
+            </a:avLst>
+          </a:prstGeom>
+          <a:solidFill>
+            <a:schemeClr val="accent6"/>
+          </a:solidFill>
+          <a:ln w="12700">
             <a:solidFill>
               <a:schemeClr val="accent6"/>
             </a:solidFill>
@@ -5527,14 +5210,14 @@
       </p:sp>
       <p:sp>
         <p:nvSpPr>
-          <p:cNvPr id="11" name="Roadmap Today circle"/>
+          <p:cNvPr id="4" name="Buy agent circle"/>
           <p:cNvSpPr/>
           <p:nvPr/>
         </p:nvSpPr>
         <p:spPr>
           <a:xfrm>
-            <a:off x="6309360" y="1554480"/>
-            <a:ext cx="548640" cy="548640"/>
+            <a:off x="777240" y="1600200"/>
+            <a:ext cx="566928" cy="566928"/>
           </a:xfrm>
           <a:prstGeom prst="ellipse">
             <a:avLst/>
@@ -5550,16 +5233,40 @@
           </a:ln>
         </p:spPr>
       </p:sp>
-      <p:sp>
-        <p:nvSpPr>
-          <p:cNvPr id="12" name="Roadmap Today number"/>
-          <p:cNvSpPr txBox="1"/>
-          <p:nvPr/>
-        </p:nvSpPr>
-        <p:spPr>
-          <a:xfrm>
-            <a:off x="6309360" y="1554480"/>
-            <a:ext cx="548640" cy="548640"/>
+      <p:pic>
+        <p:nvPicPr>
+          <p:cNvPr id="5" name="Buy agent icon" descr="preencoded.png">    </p:cNvPr>
+          <p:cNvPicPr>
+            <a:picLocks noChangeAspect="1"/>
+          </p:cNvPicPr>
+          <p:nvPr/>
+        </p:nvPicPr>
+        <p:blipFill>
+          <a:blip r:embed="rId1"/>
+          <a:stretch>
+            <a:fillRect/>
+          </a:stretch>
+        </p:blipFill>
+        <p:spPr>
+          <a:xfrm>
+            <a:off x="918972" y="1741932"/>
+            <a:ext cx="283464" cy="283464"/>
+          </a:xfrm>
+          <a:prstGeom prst="rect">
+            <a:avLst/>
+          </a:prstGeom>
+        </p:spPr>
+      </p:pic>
+      <p:sp>
+        <p:nvSpPr>
+          <p:cNvPr id="6" name="Buy heading"/>
+          <p:cNvSpPr txBox="1"/>
+          <p:nvPr/>
+        </p:nvSpPr>
+        <p:spPr>
+          <a:xfrm>
+            <a:off x="1463040" y="1600200"/>
+            <a:ext cx="1562024" cy="566928"/>
           </a:xfrm>
           <a:prstGeom prst="rect">
             <a:avLst/>
@@ -5571,31 +5278,31 @@
           <a:bodyPr wrap="square" lIns="0" tIns="0" rIns="0" bIns="0" rtlCol="0" anchor="ctr"/>
           <a:lstStyle/>
           <a:p>
-            <a:pPr algn="ctr" indent="0" marL="0">
-              <a:buNone/>
-            </a:pPr>
-            <a:r>
-              <a:rPr lang="en-US" sz="1800" b="1" dirty="0">
+            <a:pPr indent="0" marL="0">
+              <a:buNone/>
+            </a:pPr>
+            <a:r>
+              <a:rPr lang="en-US" sz="2000" b="1" dirty="0">
                 <a:solidFill>
                   <a:schemeClr val="bg1"/>
                 </a:solidFill>
               </a:rPr>
-              <a:t>1</a:t>
-            </a:r>
-            <a:endParaRPr lang="en-US" sz="1800" dirty="0"/>
-          </a:p>
-        </p:txBody>
-      </p:sp>
-      <p:sp>
-        <p:nvSpPr>
-          <p:cNvPr id="13" name="Roadmap Today heading"/>
-          <p:cNvSpPr txBox="1"/>
-          <p:nvPr/>
-        </p:nvSpPr>
-        <p:spPr>
-          <a:xfrm>
-            <a:off x="7086600" y="1536192"/>
-            <a:ext cx="4556455" cy="329184"/>
+              <a:t>Buy</a:t>
+            </a:r>
+            <a:endParaRPr lang="en-US" sz="2000" dirty="0"/>
+          </a:p>
+        </p:txBody>
+      </p:sp>
+      <p:sp>
+        <p:nvSpPr>
+          <p:cNvPr id="7" name="Buy problem label"/>
+          <p:cNvSpPr txBox="1"/>
+          <p:nvPr/>
+        </p:nvSpPr>
+        <p:spPr>
+          <a:xfrm>
+            <a:off x="777240" y="2350008"/>
+            <a:ext cx="2110664" cy="237744"/>
           </a:xfrm>
           <a:prstGeom prst="rect">
             <a:avLst/>
@@ -5611,48 +5318,120 @@
               <a:buNone/>
             </a:pPr>
             <a:r>
-              <a:rPr lang="en-US" sz="1800" b="1" dirty="0">
+              <a:rPr lang="en-US" sz="1100" b="1" spc="200" kern="0" dirty="0">
+                <a:solidFill>
+                  <a:schemeClr val="bg2"/>
+                </a:solidFill>
+              </a:rPr>
+              <a:t>THE PROBLEM</a:t>
+            </a:r>
+            <a:endParaRPr lang="en-US" sz="1100" dirty="0"/>
+          </a:p>
+        </p:txBody>
+      </p:sp>
+      <p:sp>
+        <p:nvSpPr>
+          <p:cNvPr id="8" name="Buy problem"/>
+          <p:cNvSpPr txBox="1"/>
+          <p:nvPr/>
+        </p:nvSpPr>
+        <p:spPr>
+          <a:xfrm>
+            <a:off x="777240" y="2606040"/>
+            <a:ext cx="2110664" cy="822960"/>
+          </a:xfrm>
+          <a:prstGeom prst="rect">
+            <a:avLst/>
+          </a:prstGeom>
+          <a:noFill/>
+          <a:ln/>
+        </p:spPr>
+        <p:txBody>
+          <a:bodyPr wrap="square" lIns="0" tIns="0" rIns="0" bIns="0" rtlCol="0" anchor="t"/>
+          <a:lstStyle/>
+          <a:p>
+            <a:pPr indent="0" marL="0">
+              <a:buNone/>
+            </a:pPr>
+            <a:r>
+              <a:rPr lang="en-US" sz="1400" dirty="0">
+                <a:solidFill>
+                  <a:schemeClr val="bg2"/>
+                </a:solidFill>
+              </a:rPr>
+              <a:t>Buyers scroll thousands of listings and can't see a car's full past.</a:t>
+            </a:r>
+            <a:endParaRPr lang="en-US" sz="1400" dirty="0"/>
+          </a:p>
+        </p:txBody>
+      </p:sp>
+      <p:sp>
+        <p:nvSpPr>
+          <p:cNvPr id="9" name="Buy new label"/>
+          <p:cNvSpPr txBox="1"/>
+          <p:nvPr/>
+        </p:nvSpPr>
+        <p:spPr>
+          <a:xfrm>
+            <a:off x="777240" y="3474720"/>
+            <a:ext cx="2110664" cy="237744"/>
+          </a:xfrm>
+          <a:prstGeom prst="rect">
+            <a:avLst/>
+          </a:prstGeom>
+          <a:noFill/>
+          <a:ln/>
+        </p:spPr>
+        <p:txBody>
+          <a:bodyPr wrap="square" lIns="0" tIns="0" rIns="0" bIns="0" rtlCol="0" anchor="ctr"/>
+          <a:lstStyle/>
+          <a:p>
+            <a:pPr indent="0" marL="0">
+              <a:buNone/>
+            </a:pPr>
+            <a:r>
+              <a:rPr lang="en-US" sz="1100" b="1" spc="200" kern="0" dirty="0">
+                <a:solidFill>
+                  <a:schemeClr val="accent2"/>
+                </a:solidFill>
+              </a:rPr>
+              <a:t>WHAT'S NEW</a:t>
+            </a:r>
+            <a:endParaRPr lang="en-US" sz="1100" dirty="0"/>
+          </a:p>
+        </p:txBody>
+      </p:sp>
+      <p:sp>
+        <p:nvSpPr>
+          <p:cNvPr id="10" name="Buy new"/>
+          <p:cNvSpPr txBox="1"/>
+          <p:nvPr/>
+        </p:nvSpPr>
+        <p:spPr>
+          <a:xfrm>
+            <a:off x="777240" y="3730752"/>
+            <a:ext cx="2110664" cy="1188720"/>
+          </a:xfrm>
+          <a:prstGeom prst="rect">
+            <a:avLst/>
+          </a:prstGeom>
+          <a:noFill/>
+          <a:ln/>
+        </p:spPr>
+        <p:txBody>
+          <a:bodyPr wrap="square" lIns="0" tIns="0" rIns="0" bIns="0" rtlCol="0" anchor="t"/>
+          <a:lstStyle/>
+          <a:p>
+            <a:pPr indent="0" marL="0">
+              <a:buNone/>
+            </a:pPr>
+            <a:r>
+              <a:rPr lang="en-US" sz="1400" dirty="0">
                 <a:solidFill>
                   <a:schemeClr val="bg1"/>
                 </a:solidFill>
               </a:rPr>
-              <a:t>Today</a:t>
-            </a:r>
-            <a:endParaRPr lang="en-US" sz="1800" dirty="0"/>
-          </a:p>
-        </p:txBody>
-      </p:sp>
-      <p:sp>
-        <p:nvSpPr>
-          <p:cNvPr id="14" name="Roadmap Today text"/>
-          <p:cNvSpPr txBox="1"/>
-          <p:nvPr/>
-        </p:nvSpPr>
-        <p:spPr>
-          <a:xfrm>
-            <a:off x="7086600" y="1883664"/>
-            <a:ext cx="4556455" cy="685800"/>
-          </a:xfrm>
-          <a:prstGeom prst="rect">
-            <a:avLst/>
-          </a:prstGeom>
-          <a:noFill/>
-          <a:ln/>
-        </p:spPr>
-        <p:txBody>
-          <a:bodyPr wrap="square" lIns="0" tIns="0" rIns="0" bIns="0" rtlCol="0" anchor="t"/>
-          <a:lstStyle/>
-          <a:p>
-            <a:pPr indent="0" marL="0">
-              <a:buNone/>
-            </a:pPr>
-            <a:r>
-              <a:rPr lang="en-US" sz="1400" dirty="0">
-                <a:solidFill>
-                  <a:schemeClr val="bg2"/>
-                </a:solidFill>
-              </a:rPr>
-              <a:t>4 working AI agents on demo data</a:t>
+              <a:t>One request searches both marketplaces, and the history check joins ACV + Copart records to catch washed titles.</a:t>
             </a:r>
             <a:endParaRPr lang="en-US" sz="1400" dirty="0"/>
           </a:p>
@@ -5660,14 +5439,41 @@
       </p:sp>
       <p:sp>
         <p:nvSpPr>
-          <p:cNvPr id="15" name="Roadmap Next circle"/>
+          <p:cNvPr id="11" name="Sell card"/>
           <p:cNvSpPr/>
           <p:nvPr/>
         </p:nvSpPr>
         <p:spPr>
           <a:xfrm>
-            <a:off x="6309360" y="2743200"/>
-            <a:ext cx="548640" cy="548640"/>
+            <a:off x="3390824" y="1371600"/>
+            <a:ext cx="2567864" cy="3611880"/>
+          </a:xfrm>
+          <a:prstGeom prst="roundRect">
+            <a:avLst>
+              <a:gd name="adj" fmla="val 4273"/>
+            </a:avLst>
+          </a:prstGeom>
+          <a:solidFill>
+            <a:schemeClr val="accent6"/>
+          </a:solidFill>
+          <a:ln w="12700">
+            <a:solidFill>
+              <a:schemeClr val="accent6"/>
+            </a:solidFill>
+            <a:prstDash val="solid"/>
+          </a:ln>
+        </p:spPr>
+      </p:sp>
+      <p:sp>
+        <p:nvSpPr>
+          <p:cNvPr id="12" name="Sell agent circle"/>
+          <p:cNvSpPr/>
+          <p:nvPr/>
+        </p:nvSpPr>
+        <p:spPr>
+          <a:xfrm>
+            <a:off x="3619424" y="1600200"/>
+            <a:ext cx="566928" cy="566928"/>
           </a:xfrm>
           <a:prstGeom prst="ellipse">
             <a:avLst/>
@@ -5683,16 +5489,40 @@
           </a:ln>
         </p:spPr>
       </p:sp>
-      <p:sp>
-        <p:nvSpPr>
-          <p:cNvPr id="16" name="Roadmap Next number"/>
-          <p:cNvSpPr txBox="1"/>
-          <p:nvPr/>
-        </p:nvSpPr>
-        <p:spPr>
-          <a:xfrm>
-            <a:off x="6309360" y="2743200"/>
-            <a:ext cx="548640" cy="548640"/>
+      <p:pic>
+        <p:nvPicPr>
+          <p:cNvPr id="13" name="Sell agent icon" descr="preencoded.png">    </p:cNvPr>
+          <p:cNvPicPr>
+            <a:picLocks noChangeAspect="1"/>
+          </p:cNvPicPr>
+          <p:nvPr/>
+        </p:nvPicPr>
+        <p:blipFill>
+          <a:blip r:embed="rId2"/>
+          <a:stretch>
+            <a:fillRect/>
+          </a:stretch>
+        </p:blipFill>
+        <p:spPr>
+          <a:xfrm>
+            <a:off x="3761156" y="1741932"/>
+            <a:ext cx="283464" cy="283464"/>
+          </a:xfrm>
+          <a:prstGeom prst="rect">
+            <a:avLst/>
+          </a:prstGeom>
+        </p:spPr>
+      </p:pic>
+      <p:sp>
+        <p:nvSpPr>
+          <p:cNvPr id="14" name="Sell heading"/>
+          <p:cNvSpPr txBox="1"/>
+          <p:nvPr/>
+        </p:nvSpPr>
+        <p:spPr>
+          <a:xfrm>
+            <a:off x="4305224" y="1600200"/>
+            <a:ext cx="1562024" cy="566928"/>
           </a:xfrm>
           <a:prstGeom prst="rect">
             <a:avLst/>
@@ -5704,31 +5534,31 @@
           <a:bodyPr wrap="square" lIns="0" tIns="0" rIns="0" bIns="0" rtlCol="0" anchor="ctr"/>
           <a:lstStyle/>
           <a:p>
-            <a:pPr algn="ctr" indent="0" marL="0">
-              <a:buNone/>
-            </a:pPr>
-            <a:r>
-              <a:rPr lang="en-US" sz="1800" b="1" dirty="0">
+            <a:pPr indent="0" marL="0">
+              <a:buNone/>
+            </a:pPr>
+            <a:r>
+              <a:rPr lang="en-US" sz="2000" b="1" dirty="0">
                 <a:solidFill>
                   <a:schemeClr val="bg1"/>
                 </a:solidFill>
               </a:rPr>
-              <a:t>2</a:t>
-            </a:r>
-            <a:endParaRPr lang="en-US" sz="1800" dirty="0"/>
-          </a:p>
-        </p:txBody>
-      </p:sp>
-      <p:sp>
-        <p:nvSpPr>
-          <p:cNvPr id="17" name="Roadmap Next heading"/>
-          <p:cNvSpPr txBox="1"/>
-          <p:nvPr/>
-        </p:nvSpPr>
-        <p:spPr>
-          <a:xfrm>
-            <a:off x="7086600" y="2724912"/>
-            <a:ext cx="4556455" cy="329184"/>
+              <a:t>Sell</a:t>
+            </a:r>
+            <a:endParaRPr lang="en-US" sz="2000" dirty="0"/>
+          </a:p>
+        </p:txBody>
+      </p:sp>
+      <p:sp>
+        <p:nvSpPr>
+          <p:cNvPr id="15" name="Sell problem label"/>
+          <p:cNvSpPr txBox="1"/>
+          <p:nvPr/>
+        </p:nvSpPr>
+        <p:spPr>
+          <a:xfrm>
+            <a:off x="3619424" y="2350008"/>
+            <a:ext cx="2110664" cy="237744"/>
           </a:xfrm>
           <a:prstGeom prst="rect">
             <a:avLst/>
@@ -5744,48 +5574,120 @@
               <a:buNone/>
             </a:pPr>
             <a:r>
-              <a:rPr lang="en-US" sz="1800" b="1" dirty="0">
+              <a:rPr lang="en-US" sz="1100" b="1" spc="200" kern="0" dirty="0">
+                <a:solidFill>
+                  <a:schemeClr val="bg2"/>
+                </a:solidFill>
+              </a:rPr>
+              <a:t>THE PROBLEM</a:t>
+            </a:r>
+            <a:endParaRPr lang="en-US" sz="1100" dirty="0"/>
+          </a:p>
+        </p:txBody>
+      </p:sp>
+      <p:sp>
+        <p:nvSpPr>
+          <p:cNvPr id="16" name="Sell problem"/>
+          <p:cNvSpPr txBox="1"/>
+          <p:nvPr/>
+        </p:nvSpPr>
+        <p:spPr>
+          <a:xfrm>
+            <a:off x="3619424" y="2606040"/>
+            <a:ext cx="2110664" cy="822960"/>
+          </a:xfrm>
+          <a:prstGeom prst="rect">
+            <a:avLst/>
+          </a:prstGeom>
+          <a:noFill/>
+          <a:ln/>
+        </p:spPr>
+        <p:txBody>
+          <a:bodyPr wrap="square" lIns="0" tIns="0" rIns="0" bIns="0" rtlCol="0" anchor="t"/>
+          <a:lstStyle/>
+          <a:p>
+            <a:pPr indent="0" marL="0">
+              <a:buNone/>
+            </a:pPr>
+            <a:r>
+              <a:rPr lang="en-US" sz="1400" dirty="0">
+                <a:solidFill>
+                  <a:schemeClr val="bg2"/>
+                </a:solidFill>
+              </a:rPr>
+              <a:t>The right buyer often misses the 20-minute auction.</a:t>
+            </a:r>
+            <a:endParaRPr lang="en-US" sz="1400" dirty="0"/>
+          </a:p>
+        </p:txBody>
+      </p:sp>
+      <p:sp>
+        <p:nvSpPr>
+          <p:cNvPr id="17" name="Sell new label"/>
+          <p:cNvSpPr txBox="1"/>
+          <p:nvPr/>
+        </p:nvSpPr>
+        <p:spPr>
+          <a:xfrm>
+            <a:off x="3619424" y="3474720"/>
+            <a:ext cx="2110664" cy="237744"/>
+          </a:xfrm>
+          <a:prstGeom prst="rect">
+            <a:avLst/>
+          </a:prstGeom>
+          <a:noFill/>
+          <a:ln/>
+        </p:spPr>
+        <p:txBody>
+          <a:bodyPr wrap="square" lIns="0" tIns="0" rIns="0" bIns="0" rtlCol="0" anchor="ctr"/>
+          <a:lstStyle/>
+          <a:p>
+            <a:pPr indent="0" marL="0">
+              <a:buNone/>
+            </a:pPr>
+            <a:r>
+              <a:rPr lang="en-US" sz="1100" b="1" spc="200" kern="0" dirty="0">
+                <a:solidFill>
+                  <a:schemeClr val="accent2"/>
+                </a:solidFill>
+              </a:rPr>
+              <a:t>WHAT'S NEW</a:t>
+            </a:r>
+            <a:endParaRPr lang="en-US" sz="1100" dirty="0"/>
+          </a:p>
+        </p:txBody>
+      </p:sp>
+      <p:sp>
+        <p:nvSpPr>
+          <p:cNvPr id="18" name="Sell new"/>
+          <p:cNvSpPr txBox="1"/>
+          <p:nvPr/>
+        </p:nvSpPr>
+        <p:spPr>
+          <a:xfrm>
+            <a:off x="3619424" y="3730752"/>
+            <a:ext cx="2110664" cy="1188720"/>
+          </a:xfrm>
+          <a:prstGeom prst="rect">
+            <a:avLst/>
+          </a:prstGeom>
+          <a:noFill/>
+          <a:ln/>
+        </p:spPr>
+        <p:txBody>
+          <a:bodyPr wrap="square" lIns="0" tIns="0" rIns="0" bIns="0" rtlCol="0" anchor="t"/>
+          <a:lstStyle/>
+          <a:p>
+            <a:pPr indent="0" marL="0">
+              <a:buNone/>
+            </a:pPr>
+            <a:r>
+              <a:rPr lang="en-US" sz="1400" dirty="0">
                 <a:solidFill>
                   <a:schemeClr val="bg1"/>
                 </a:solidFill>
               </a:rPr>
-              <a:t>Next</a:t>
-            </a:r>
-            <a:endParaRPr lang="en-US" sz="1800" dirty="0"/>
-          </a:p>
-        </p:txBody>
-      </p:sp>
-      <p:sp>
-        <p:nvSpPr>
-          <p:cNvPr id="18" name="Roadmap Next text"/>
-          <p:cNvSpPr txBox="1"/>
-          <p:nvPr/>
-        </p:nvSpPr>
-        <p:spPr>
-          <a:xfrm>
-            <a:off x="7086600" y="3072384"/>
-            <a:ext cx="4556455" cy="685800"/>
-          </a:xfrm>
-          <a:prstGeom prst="rect">
-            <a:avLst/>
-          </a:prstGeom>
-          <a:noFill/>
-          <a:ln/>
-        </p:spPr>
-        <p:txBody>
-          <a:bodyPr wrap="square" lIns="0" tIns="0" rIns="0" bIns="0" rtlCol="0" anchor="t"/>
-          <a:lstStyle/>
-          <a:p>
-            <a:pPr indent="0" marL="0">
-              <a:buNone/>
-            </a:pPr>
-            <a:r>
-              <a:rPr lang="en-US" sz="1400" dirty="0">
-                <a:solidFill>
-                  <a:schemeClr val="bg2"/>
-                </a:solidFill>
-              </a:rPr>
-              <a:t>Connect to ACV + Copart inventory, inspections, financing and transport</a:t>
+              <a:t>The car finds its buyer: saved requests are matched and alerted before the auction starts.</a:t>
             </a:r>
             <a:endParaRPr lang="en-US" sz="1400" dirty="0"/>
           </a:p>
@@ -5793,14 +5695,41 @@
       </p:sp>
       <p:sp>
         <p:nvSpPr>
-          <p:cNvPr id="19" name="Roadmap Then circle"/>
+          <p:cNvPr id="19" name="Negotiate card"/>
           <p:cNvSpPr/>
           <p:nvPr/>
         </p:nvSpPr>
         <p:spPr>
           <a:xfrm>
-            <a:off x="6309360" y="3931920"/>
-            <a:ext cx="548640" cy="548640"/>
+            <a:off x="6233008" y="1371600"/>
+            <a:ext cx="2567864" cy="3611880"/>
+          </a:xfrm>
+          <a:prstGeom prst="roundRect">
+            <a:avLst>
+              <a:gd name="adj" fmla="val 4273"/>
+            </a:avLst>
+          </a:prstGeom>
+          <a:solidFill>
+            <a:schemeClr val="accent6"/>
+          </a:solidFill>
+          <a:ln w="12700">
+            <a:solidFill>
+              <a:schemeClr val="accent6"/>
+            </a:solidFill>
+            <a:prstDash val="solid"/>
+          </a:ln>
+        </p:spPr>
+      </p:sp>
+      <p:sp>
+        <p:nvSpPr>
+          <p:cNvPr id="20" name="Negotiate agent circle"/>
+          <p:cNvSpPr/>
+          <p:nvPr/>
+        </p:nvSpPr>
+        <p:spPr>
+          <a:xfrm>
+            <a:off x="6461608" y="1600200"/>
+            <a:ext cx="566928" cy="566928"/>
           </a:xfrm>
           <a:prstGeom prst="ellipse">
             <a:avLst/>
@@ -5816,16 +5745,40 @@
           </a:ln>
         </p:spPr>
       </p:sp>
-      <p:sp>
-        <p:nvSpPr>
-          <p:cNvPr id="20" name="Roadmap Then number"/>
-          <p:cNvSpPr txBox="1"/>
-          <p:nvPr/>
-        </p:nvSpPr>
-        <p:spPr>
-          <a:xfrm>
-            <a:off x="6309360" y="3931920"/>
-            <a:ext cx="548640" cy="548640"/>
+      <p:pic>
+        <p:nvPicPr>
+          <p:cNvPr id="21" name="Negotiate agent icon" descr="preencoded.png">    </p:cNvPr>
+          <p:cNvPicPr>
+            <a:picLocks noChangeAspect="1"/>
+          </p:cNvPicPr>
+          <p:nvPr/>
+        </p:nvPicPr>
+        <p:blipFill>
+          <a:blip r:embed="rId3"/>
+          <a:stretch>
+            <a:fillRect/>
+          </a:stretch>
+        </p:blipFill>
+        <p:spPr>
+          <a:xfrm>
+            <a:off x="6603340" y="1741932"/>
+            <a:ext cx="283464" cy="283464"/>
+          </a:xfrm>
+          <a:prstGeom prst="rect">
+            <a:avLst/>
+          </a:prstGeom>
+        </p:spPr>
+      </p:pic>
+      <p:sp>
+        <p:nvSpPr>
+          <p:cNvPr id="22" name="Negotiate heading"/>
+          <p:cNvSpPr txBox="1"/>
+          <p:nvPr/>
+        </p:nvSpPr>
+        <p:spPr>
+          <a:xfrm>
+            <a:off x="7147408" y="1600200"/>
+            <a:ext cx="1562024" cy="566928"/>
           </a:xfrm>
           <a:prstGeom prst="rect">
             <a:avLst/>
@@ -5837,31 +5790,31 @@
           <a:bodyPr wrap="square" lIns="0" tIns="0" rIns="0" bIns="0" rtlCol="0" anchor="ctr"/>
           <a:lstStyle/>
           <a:p>
-            <a:pPr algn="ctr" indent="0" marL="0">
-              <a:buNone/>
-            </a:pPr>
-            <a:r>
-              <a:rPr lang="en-US" sz="1800" b="1" dirty="0">
+            <a:pPr indent="0" marL="0">
+              <a:buNone/>
+            </a:pPr>
+            <a:r>
+              <a:rPr lang="en-US" sz="2000" b="1" dirty="0">
                 <a:solidFill>
                   <a:schemeClr val="bg1"/>
                 </a:solidFill>
               </a:rPr>
-              <a:t>3</a:t>
-            </a:r>
-            <a:endParaRPr lang="en-US" sz="1800" dirty="0"/>
-          </a:p>
-        </p:txBody>
-      </p:sp>
-      <p:sp>
-        <p:nvSpPr>
-          <p:cNvPr id="21" name="Roadmap Then heading"/>
-          <p:cNvSpPr txBox="1"/>
-          <p:nvPr/>
-        </p:nvSpPr>
-        <p:spPr>
-          <a:xfrm>
-            <a:off x="7086600" y="3913632"/>
-            <a:ext cx="4556455" cy="329184"/>
+              <a:t>Negotiate</a:t>
+            </a:r>
+            <a:endParaRPr lang="en-US" sz="2000" dirty="0"/>
+          </a:p>
+        </p:txBody>
+      </p:sp>
+      <p:sp>
+        <p:nvSpPr>
+          <p:cNvPr id="23" name="Negotiate problem label"/>
+          <p:cNvSpPr txBox="1"/>
+          <p:nvPr/>
+        </p:nvSpPr>
+        <p:spPr>
+          <a:xfrm>
+            <a:off x="6461608" y="2350008"/>
+            <a:ext cx="2110664" cy="237744"/>
           </a:xfrm>
           <a:prstGeom prst="rect">
             <a:avLst/>
@@ -5877,27 +5830,283 @@
               <a:buNone/>
             </a:pPr>
             <a:r>
-              <a:rPr lang="en-US" sz="1800" b="1" dirty="0">
+              <a:rPr lang="en-US" sz="1100" b="1" spc="200" kern="0" dirty="0">
+                <a:solidFill>
+                  <a:schemeClr val="bg2"/>
+                </a:solidFill>
+              </a:rPr>
+              <a:t>THE PROBLEM</a:t>
+            </a:r>
+            <a:endParaRPr lang="en-US" sz="1100" dirty="0"/>
+          </a:p>
+        </p:txBody>
+      </p:sp>
+      <p:sp>
+        <p:nvSpPr>
+          <p:cNvPr id="24" name="Negotiate problem"/>
+          <p:cNvSpPr txBox="1"/>
+          <p:nvPr/>
+        </p:nvSpPr>
+        <p:spPr>
+          <a:xfrm>
+            <a:off x="6461608" y="2606040"/>
+            <a:ext cx="2110664" cy="822960"/>
+          </a:xfrm>
+          <a:prstGeom prst="rect">
+            <a:avLst/>
+          </a:prstGeom>
+          <a:noFill/>
+          <a:ln/>
+        </p:spPr>
+        <p:txBody>
+          <a:bodyPr wrap="square" lIns="0" tIns="0" rIns="0" bIns="0" rtlCol="0" anchor="t"/>
+          <a:lstStyle/>
+          <a:p>
+            <a:pPr indent="0" marL="0">
+              <a:buNone/>
+            </a:pPr>
+            <a:r>
+              <a:rPr lang="en-US" sz="1400" dirty="0">
+                <a:solidFill>
+                  <a:schemeClr val="bg2"/>
+                </a:solidFill>
+              </a:rPr>
+              <a:t>When the ask is above the top bid, the sale just dies.</a:t>
+            </a:r>
+            <a:endParaRPr lang="en-US" sz="1400" dirty="0"/>
+          </a:p>
+        </p:txBody>
+      </p:sp>
+      <p:sp>
+        <p:nvSpPr>
+          <p:cNvPr id="25" name="Negotiate new label"/>
+          <p:cNvSpPr txBox="1"/>
+          <p:nvPr/>
+        </p:nvSpPr>
+        <p:spPr>
+          <a:xfrm>
+            <a:off x="6461608" y="3474720"/>
+            <a:ext cx="2110664" cy="237744"/>
+          </a:xfrm>
+          <a:prstGeom prst="rect">
+            <a:avLst/>
+          </a:prstGeom>
+          <a:noFill/>
+          <a:ln/>
+        </p:spPr>
+        <p:txBody>
+          <a:bodyPr wrap="square" lIns="0" tIns="0" rIns="0" bIns="0" rtlCol="0" anchor="ctr"/>
+          <a:lstStyle/>
+          <a:p>
+            <a:pPr indent="0" marL="0">
+              <a:buNone/>
+            </a:pPr>
+            <a:r>
+              <a:rPr lang="en-US" sz="1100" b="1" spc="200" kern="0" dirty="0">
+                <a:solidFill>
+                  <a:schemeClr val="accent2"/>
+                </a:solidFill>
+              </a:rPr>
+              <a:t>WHAT'S NEW</a:t>
+            </a:r>
+            <a:endParaRPr lang="en-US" sz="1100" dirty="0"/>
+          </a:p>
+        </p:txBody>
+      </p:sp>
+      <p:sp>
+        <p:nvSpPr>
+          <p:cNvPr id="26" name="Negotiate new"/>
+          <p:cNvSpPr txBox="1"/>
+          <p:nvPr/>
+        </p:nvSpPr>
+        <p:spPr>
+          <a:xfrm>
+            <a:off x="6461608" y="3730752"/>
+            <a:ext cx="2110664" cy="1188720"/>
+          </a:xfrm>
+          <a:prstGeom prst="rect">
+            <a:avLst/>
+          </a:prstGeom>
+          <a:noFill/>
+          <a:ln/>
+        </p:spPr>
+        <p:txBody>
+          <a:bodyPr wrap="square" lIns="0" tIns="0" rIns="0" bIns="0" rtlCol="0" anchor="t"/>
+          <a:lstStyle/>
+          <a:p>
+            <a:pPr indent="0" marL="0">
+              <a:buNone/>
+            </a:pPr>
+            <a:r>
+              <a:rPr lang="en-US" sz="1400" dirty="0">
                 <a:solidFill>
                   <a:schemeClr val="bg1"/>
                 </a:solidFill>
               </a:rPr>
-              <a:t>Then</a:t>
-            </a:r>
-            <a:endParaRPr lang="en-US" sz="1800" dirty="0"/>
-          </a:p>
-        </p:txBody>
-      </p:sp>
-      <p:sp>
-        <p:nvSpPr>
-          <p:cNvPr id="22" name="Roadmap Then text"/>
-          <p:cNvSpPr txBox="1"/>
-          <p:nvPr/>
-        </p:nvSpPr>
-        <p:spPr>
-          <a:xfrm>
-            <a:off x="7086600" y="4261104"/>
-            <a:ext cx="4556455" cy="685800"/>
+              <a:t>An AI mediator works with each side's private limit, then closes the deal: payment, insurance, loan payoff, title, truck.</a:t>
+            </a:r>
+            <a:endParaRPr lang="en-US" sz="1400" dirty="0"/>
+          </a:p>
+        </p:txBody>
+      </p:sp>
+      <p:sp>
+        <p:nvSpPr>
+          <p:cNvPr id="27" name="Fleet card"/>
+          <p:cNvSpPr/>
+          <p:nvPr/>
+        </p:nvSpPr>
+        <p:spPr>
+          <a:xfrm>
+            <a:off x="9075191" y="1371600"/>
+            <a:ext cx="2567864" cy="3611880"/>
+          </a:xfrm>
+          <a:prstGeom prst="roundRect">
+            <a:avLst>
+              <a:gd name="adj" fmla="val 4273"/>
+            </a:avLst>
+          </a:prstGeom>
+          <a:solidFill>
+            <a:schemeClr val="accent6"/>
+          </a:solidFill>
+          <a:ln w="12700">
+            <a:solidFill>
+              <a:schemeClr val="accent6"/>
+            </a:solidFill>
+            <a:prstDash val="solid"/>
+          </a:ln>
+        </p:spPr>
+      </p:sp>
+      <p:sp>
+        <p:nvSpPr>
+          <p:cNvPr id="28" name="Fleet agent circle"/>
+          <p:cNvSpPr/>
+          <p:nvPr/>
+        </p:nvSpPr>
+        <p:spPr>
+          <a:xfrm>
+            <a:off x="9303791" y="1600200"/>
+            <a:ext cx="566928" cy="566928"/>
+          </a:xfrm>
+          <a:prstGeom prst="ellipse">
+            <a:avLst/>
+          </a:prstGeom>
+          <a:solidFill>
+            <a:schemeClr val="accent1"/>
+          </a:solidFill>
+          <a:ln w="12700">
+            <a:solidFill>
+              <a:schemeClr val="accent1"/>
+            </a:solidFill>
+            <a:prstDash val="solid"/>
+          </a:ln>
+        </p:spPr>
+      </p:sp>
+      <p:pic>
+        <p:nvPicPr>
+          <p:cNvPr id="29" name="Fleet agent icon" descr="preencoded.png">    </p:cNvPr>
+          <p:cNvPicPr>
+            <a:picLocks noChangeAspect="1"/>
+          </p:cNvPicPr>
+          <p:nvPr/>
+        </p:nvPicPr>
+        <p:blipFill>
+          <a:blip r:embed="rId4"/>
+          <a:stretch>
+            <a:fillRect/>
+          </a:stretch>
+        </p:blipFill>
+        <p:spPr>
+          <a:xfrm>
+            <a:off x="9445523" y="1741932"/>
+            <a:ext cx="283464" cy="283464"/>
+          </a:xfrm>
+          <a:prstGeom prst="rect">
+            <a:avLst/>
+          </a:prstGeom>
+        </p:spPr>
+      </p:pic>
+      <p:sp>
+        <p:nvSpPr>
+          <p:cNvPr id="30" name="Fleet heading"/>
+          <p:cNvSpPr txBox="1"/>
+          <p:nvPr/>
+        </p:nvSpPr>
+        <p:spPr>
+          <a:xfrm>
+            <a:off x="9989591" y="1600200"/>
+            <a:ext cx="1562024" cy="566928"/>
+          </a:xfrm>
+          <a:prstGeom prst="rect">
+            <a:avLst/>
+          </a:prstGeom>
+          <a:noFill/>
+          <a:ln/>
+        </p:spPr>
+        <p:txBody>
+          <a:bodyPr wrap="square" lIns="0" tIns="0" rIns="0" bIns="0" rtlCol="0" anchor="ctr"/>
+          <a:lstStyle/>
+          <a:p>
+            <a:pPr indent="0" marL="0">
+              <a:buNone/>
+            </a:pPr>
+            <a:r>
+              <a:rPr lang="en-US" sz="2000" b="1" dirty="0">
+                <a:solidFill>
+                  <a:schemeClr val="bg1"/>
+                </a:solidFill>
+              </a:rPr>
+              <a:t>Fleet</a:t>
+            </a:r>
+            <a:endParaRPr lang="en-US" sz="2000" dirty="0"/>
+          </a:p>
+        </p:txBody>
+      </p:sp>
+      <p:sp>
+        <p:nvSpPr>
+          <p:cNvPr id="31" name="Fleet problem label"/>
+          <p:cNvSpPr txBox="1"/>
+          <p:nvPr/>
+        </p:nvSpPr>
+        <p:spPr>
+          <a:xfrm>
+            <a:off x="9303791" y="2350008"/>
+            <a:ext cx="2110664" cy="237744"/>
+          </a:xfrm>
+          <a:prstGeom prst="rect">
+            <a:avLst/>
+          </a:prstGeom>
+          <a:noFill/>
+          <a:ln/>
+        </p:spPr>
+        <p:txBody>
+          <a:bodyPr wrap="square" lIns="0" tIns="0" rIns="0" bIns="0" rtlCol="0" anchor="ctr"/>
+          <a:lstStyle/>
+          <a:p>
+            <a:pPr indent="0" marL="0">
+              <a:buNone/>
+            </a:pPr>
+            <a:r>
+              <a:rPr lang="en-US" sz="1100" b="1" spc="200" kern="0" dirty="0">
+                <a:solidFill>
+                  <a:schemeClr val="bg2"/>
+                </a:solidFill>
+              </a:rPr>
+              <a:t>THE PROBLEM</a:t>
+            </a:r>
+            <a:endParaRPr lang="en-US" sz="1100" dirty="0"/>
+          </a:p>
+        </p:txBody>
+      </p:sp>
+      <p:sp>
+        <p:nvSpPr>
+          <p:cNvPr id="32" name="Fleet problem"/>
+          <p:cNvSpPr txBox="1"/>
+          <p:nvPr/>
+        </p:nvSpPr>
+        <p:spPr>
+          <a:xfrm>
+            <a:off x="9303791" y="2606040"/>
+            <a:ext cx="2110664" cy="822960"/>
           </a:xfrm>
           <a:prstGeom prst="rect">
             <a:avLst/>
@@ -5918,7 +6127,7 @@
                   <a:schemeClr val="bg2"/>
                 </a:solidFill>
               </a:rPr>
-              <a:t>Car Health Score for lenders and insurers, more overseas buyers, consumer sellers</a:t>
+              <a:t>Hundreds of similar cars at once crash prices, and single trips eat the margin.</a:t>
             </a:r>
             <a:endParaRPr lang="en-US" sz="1400" dirty="0"/>
           </a:p>
@@ -5926,13 +6135,154 @@
       </p:sp>
       <p:sp>
         <p:nvSpPr>
-          <p:cNvPr id="23" name="Closing line"/>
-          <p:cNvSpPr txBox="1"/>
-          <p:nvPr/>
-        </p:nvSpPr>
-        <p:spPr>
-          <a:xfrm>
-            <a:off x="548640" y="5440680"/>
+          <p:cNvPr id="33" name="Fleet new label"/>
+          <p:cNvSpPr txBox="1"/>
+          <p:nvPr/>
+        </p:nvSpPr>
+        <p:spPr>
+          <a:xfrm>
+            <a:off x="9303791" y="3474720"/>
+            <a:ext cx="2110664" cy="237744"/>
+          </a:xfrm>
+          <a:prstGeom prst="rect">
+            <a:avLst/>
+          </a:prstGeom>
+          <a:noFill/>
+          <a:ln/>
+        </p:spPr>
+        <p:txBody>
+          <a:bodyPr wrap="square" lIns="0" tIns="0" rIns="0" bIns="0" rtlCol="0" anchor="ctr"/>
+          <a:lstStyle/>
+          <a:p>
+            <a:pPr indent="0" marL="0">
+              <a:buNone/>
+            </a:pPr>
+            <a:r>
+              <a:rPr lang="en-US" sz="1100" b="1" spc="200" kern="0" dirty="0">
+                <a:solidFill>
+                  <a:schemeClr val="accent2"/>
+                </a:solidFill>
+              </a:rPr>
+              <a:t>WHAT'S NEW</a:t>
+            </a:r>
+            <a:endParaRPr lang="en-US" sz="1100" dirty="0"/>
+          </a:p>
+        </p:txBody>
+      </p:sp>
+      <p:sp>
+        <p:nvSpPr>
+          <p:cNvPr id="34" name="Fleet new"/>
+          <p:cNvSpPr txBox="1"/>
+          <p:nvPr/>
+        </p:nvSpPr>
+        <p:spPr>
+          <a:xfrm>
+            <a:off x="9303791" y="3730752"/>
+            <a:ext cx="2110664" cy="1188720"/>
+          </a:xfrm>
+          <a:prstGeom prst="rect">
+            <a:avLst/>
+          </a:prstGeom>
+          <a:noFill/>
+          <a:ln/>
+        </p:spPr>
+        <p:txBody>
+          <a:bodyPr wrap="square" lIns="0" tIns="0" rIns="0" bIns="0" rtlCol="0" anchor="t"/>
+          <a:lstStyle/>
+          <a:p>
+            <a:pPr indent="0" marL="0">
+              <a:buNone/>
+            </a:pPr>
+            <a:r>
+              <a:rPr lang="en-US" sz="1400" dirty="0">
+                <a:solidFill>
+                  <a:schemeClr val="bg1"/>
+                </a:solidFill>
+              </a:rPr>
+              <a:t>Plans where every truckload goes, market by market and week by week, so prices hold.</a:t>
+            </a:r>
+            <a:endParaRPr lang="en-US" sz="1400" dirty="0"/>
+          </a:p>
+        </p:txBody>
+      </p:sp>
+      <p:sp>
+        <p:nvSpPr>
+          <p:cNvPr id="35" name="Roadmap line"/>
+          <p:cNvSpPr txBox="1"/>
+          <p:nvPr/>
+        </p:nvSpPr>
+        <p:spPr>
+          <a:xfrm>
+            <a:off x="548640" y="5138928"/>
+            <a:ext cx="11094415" cy="347472"/>
+          </a:xfrm>
+          <a:prstGeom prst="rect">
+            <a:avLst/>
+          </a:prstGeom>
+          <a:noFill/>
+          <a:ln/>
+        </p:spPr>
+        <p:txBody>
+          <a:bodyPr wrap="square" lIns="0" tIns="0" rIns="0" bIns="0" rtlCol="0" anchor="ctr"/>
+          <a:lstStyle/>
+          <a:p>
+            <a:pPr indent="0" marL="0">
+              <a:buNone/>
+            </a:pPr>
+            <a:r>
+              <a:rPr lang="en-US" sz="1400" b="1" dirty="0">
+                <a:solidFill>
+                  <a:schemeClr val="accent2"/>
+                </a:solidFill>
+              </a:rPr>
+              <a:t>Next: </a:t>
+            </a:r>
+            <a:pPr indent="0" marL="0">
+              <a:buNone/>
+            </a:pPr>
+            <a:r>
+              <a:rPr lang="en-US" sz="1400" dirty="0">
+                <a:solidFill>
+                  <a:schemeClr val="bg1"/>
+                </a:solidFill>
+              </a:rPr>
+              <a:t>connect to ACV + Copart inventory, inspections, financing and transport.  </a:t>
+            </a:r>
+            <a:pPr indent="0" marL="0">
+              <a:buNone/>
+            </a:pPr>
+            <a:r>
+              <a:rPr lang="en-US" sz="1400" b="1" dirty="0">
+                <a:solidFill>
+                  <a:schemeClr val="accent2"/>
+                </a:solidFill>
+              </a:rPr>
+              <a:t>Then: </a:t>
+            </a:r>
+            <a:pPr indent="0" marL="0">
+              <a:buNone/>
+            </a:pPr>
+            <a:r>
+              <a:rPr lang="en-US" sz="1400" dirty="0">
+                <a:solidFill>
+                  <a:schemeClr val="bg1"/>
+                </a:solidFill>
+              </a:rPr>
+              <a:t>a Car Health Score for lenders and insurers.</a:t>
+            </a:r>
+            <a:endParaRPr lang="en-US" sz="1400" dirty="0"/>
+          </a:p>
+        </p:txBody>
+      </p:sp>
+      <p:sp>
+        <p:nvSpPr>
+          <p:cNvPr id="36" name="Closing line"/>
+          <p:cNvSpPr txBox="1"/>
+          <p:nvPr/>
+        </p:nvSpPr>
+        <p:spPr>
+          <a:xfrm>
+            <a:off x="548640" y="5596128"/>
             <a:ext cx="11094415" cy="566928"/>
           </a:xfrm>
           <a:prstGeom prst="rect">
@@ -5974,42 +6324,6 @@
               <a:t>SOLD.</a:t>
             </a:r>
             <a:endParaRPr lang="en-US" sz="3000" dirty="0"/>
-          </a:p>
-        </p:txBody>
-      </p:sp>
-      <p:sp>
-        <p:nvSpPr>
-          <p:cNvPr id="24" name="Mentor note"/>
-          <p:cNvSpPr txBox="1"/>
-          <p:nvPr/>
-        </p:nvSpPr>
-        <p:spPr>
-          <a:xfrm>
-            <a:off x="548640" y="5989320"/>
-            <a:ext cx="11094415" cy="292608"/>
-          </a:xfrm>
-          <a:prstGeom prst="rect">
-            <a:avLst/>
-          </a:prstGeom>
-          <a:noFill/>
-          <a:ln/>
-        </p:spPr>
-        <p:txBody>
-          <a:bodyPr wrap="square" lIns="0" tIns="0" rIns="0" bIns="0" rtlCol="0" anchor="ctr"/>
-          <a:lstStyle/>
-          <a:p>
-            <a:pPr algn="ctr" indent="0" marL="0">
-              <a:buNone/>
-            </a:pPr>
-            <a:r>
-              <a:rPr lang="en-US" sz="1200" dirty="0">
-                <a:solidFill>
-                  <a:schemeClr val="bg2"/>
-                </a:solidFill>
-              </a:rPr>
-              <a:t>Shaped by feedback from ACV mentors at the hackathon</a:t>
-            </a:r>
-            <a:endParaRPr lang="en-US" sz="1200" dirty="0"/>
           </a:p>
         </p:txBody>
       </p:sp>

</xml_diff>